<commit_message>
Initial commit: medical assistant project
</commit_message>
<xml_diff>
--- a/医智助手-项目答辩.pptx
+++ b/医智助手-项目答辩.pptx
@@ -15521,7 +15521,11 @@
         <p:nvSpPr>
           <p:cNvPr id="9" name="Rounded Rectangle 8"/>
           <p:cNvSpPr/>
-          <p:nvPr/>
+          <p:nvPr>
+            <p:custDataLst>
+              <p:tags r:id="rId1"/>
+            </p:custDataLst>
+          </p:nvPr>
         </p:nvSpPr>
         <p:spPr>
           <a:xfrm>
@@ -15569,7 +15573,11 @@
         <p:nvSpPr>
           <p:cNvPr id="10" name="Rounded Rectangle 9"/>
           <p:cNvSpPr/>
-          <p:nvPr/>
+          <p:nvPr>
+            <p:custDataLst>
+              <p:tags r:id="rId2"/>
+            </p:custDataLst>
+          </p:nvPr>
         </p:nvSpPr>
         <p:spPr>
           <a:xfrm>
@@ -15615,7 +15623,11 @@
         <p:nvSpPr>
           <p:cNvPr id="11" name="Rectangle 10"/>
           <p:cNvSpPr/>
-          <p:nvPr/>
+          <p:nvPr>
+            <p:custDataLst>
+              <p:tags r:id="rId3"/>
+            </p:custDataLst>
+          </p:nvPr>
         </p:nvSpPr>
         <p:spPr>
           <a:xfrm>
@@ -15659,7 +15671,11 @@
         <p:nvSpPr>
           <p:cNvPr id="12" name="TextBox 11"/>
           <p:cNvSpPr txBox="1"/>
-          <p:nvPr/>
+          <p:nvPr>
+            <p:custDataLst>
+              <p:tags r:id="rId4"/>
+            </p:custDataLst>
+          </p:nvPr>
         </p:nvSpPr>
         <p:spPr>
           <a:xfrm>
@@ -15712,7 +15728,11 @@
         <p:nvSpPr>
           <p:cNvPr id="13" name="TextBox 12"/>
           <p:cNvSpPr txBox="1"/>
-          <p:nvPr/>
+          <p:nvPr>
+            <p:custDataLst>
+              <p:tags r:id="rId5"/>
+            </p:custDataLst>
+          </p:nvPr>
         </p:nvSpPr>
         <p:spPr>
           <a:xfrm>
@@ -15846,7 +15866,11 @@
         <p:nvSpPr>
           <p:cNvPr id="14" name="Rounded Rectangle 13"/>
           <p:cNvSpPr/>
-          <p:nvPr/>
+          <p:nvPr>
+            <p:custDataLst>
+              <p:tags r:id="rId6"/>
+            </p:custDataLst>
+          </p:nvPr>
         </p:nvSpPr>
         <p:spPr>
           <a:xfrm>
@@ -15894,7 +15918,11 @@
         <p:nvSpPr>
           <p:cNvPr id="15" name="Rounded Rectangle 14"/>
           <p:cNvSpPr/>
-          <p:nvPr/>
+          <p:nvPr>
+            <p:custDataLst>
+              <p:tags r:id="rId7"/>
+            </p:custDataLst>
+          </p:nvPr>
         </p:nvSpPr>
         <p:spPr>
           <a:xfrm>
@@ -15940,7 +15968,11 @@
         <p:nvSpPr>
           <p:cNvPr id="16" name="Rectangle 15"/>
           <p:cNvSpPr/>
-          <p:nvPr/>
+          <p:nvPr>
+            <p:custDataLst>
+              <p:tags r:id="rId8"/>
+            </p:custDataLst>
+          </p:nvPr>
         </p:nvSpPr>
         <p:spPr>
           <a:xfrm>
@@ -15984,7 +16016,11 @@
         <p:nvSpPr>
           <p:cNvPr id="17" name="TextBox 16"/>
           <p:cNvSpPr txBox="1"/>
-          <p:nvPr/>
+          <p:nvPr>
+            <p:custDataLst>
+              <p:tags r:id="rId9"/>
+            </p:custDataLst>
+          </p:nvPr>
         </p:nvSpPr>
         <p:spPr>
           <a:xfrm>
@@ -16037,7 +16073,11 @@
         <p:nvSpPr>
           <p:cNvPr id="18" name="TextBox 17"/>
           <p:cNvSpPr txBox="1"/>
-          <p:nvPr/>
+          <p:nvPr>
+            <p:custDataLst>
+              <p:tags r:id="rId10"/>
+            </p:custDataLst>
+          </p:nvPr>
         </p:nvSpPr>
         <p:spPr>
           <a:xfrm>
@@ -16171,7 +16211,11 @@
         <p:nvSpPr>
           <p:cNvPr id="19" name="Rounded Rectangle 18"/>
           <p:cNvSpPr/>
-          <p:nvPr/>
+          <p:nvPr>
+            <p:custDataLst>
+              <p:tags r:id="rId11"/>
+            </p:custDataLst>
+          </p:nvPr>
         </p:nvSpPr>
         <p:spPr>
           <a:xfrm>
@@ -16219,7 +16263,11 @@
         <p:nvSpPr>
           <p:cNvPr id="20" name="Rounded Rectangle 19"/>
           <p:cNvSpPr/>
-          <p:nvPr/>
+          <p:nvPr>
+            <p:custDataLst>
+              <p:tags r:id="rId12"/>
+            </p:custDataLst>
+          </p:nvPr>
         </p:nvSpPr>
         <p:spPr>
           <a:xfrm>
@@ -16265,7 +16313,11 @@
         <p:nvSpPr>
           <p:cNvPr id="21" name="Rectangle 20"/>
           <p:cNvSpPr/>
-          <p:nvPr/>
+          <p:nvPr>
+            <p:custDataLst>
+              <p:tags r:id="rId13"/>
+            </p:custDataLst>
+          </p:nvPr>
         </p:nvSpPr>
         <p:spPr>
           <a:xfrm>
@@ -16309,7 +16361,11 @@
         <p:nvSpPr>
           <p:cNvPr id="22" name="TextBox 21"/>
           <p:cNvSpPr txBox="1"/>
-          <p:nvPr/>
+          <p:nvPr>
+            <p:custDataLst>
+              <p:tags r:id="rId14"/>
+            </p:custDataLst>
+          </p:nvPr>
         </p:nvSpPr>
         <p:spPr>
           <a:xfrm>
@@ -16362,7 +16418,11 @@
         <p:nvSpPr>
           <p:cNvPr id="23" name="TextBox 22"/>
           <p:cNvSpPr txBox="1"/>
-          <p:nvPr/>
+          <p:nvPr>
+            <p:custDataLst>
+              <p:tags r:id="rId15"/>
+            </p:custDataLst>
+          </p:nvPr>
         </p:nvSpPr>
         <p:spPr>
           <a:xfrm>
@@ -16496,7 +16556,11 @@
         <p:nvSpPr>
           <p:cNvPr id="24" name="Rounded Rectangle 23"/>
           <p:cNvSpPr/>
-          <p:nvPr/>
+          <p:nvPr>
+            <p:custDataLst>
+              <p:tags r:id="rId16"/>
+            </p:custDataLst>
+          </p:nvPr>
         </p:nvSpPr>
         <p:spPr>
           <a:xfrm>
@@ -16544,7 +16608,11 @@
         <p:nvSpPr>
           <p:cNvPr id="25" name="Rounded Rectangle 24"/>
           <p:cNvSpPr/>
-          <p:nvPr/>
+          <p:nvPr>
+            <p:custDataLst>
+              <p:tags r:id="rId17"/>
+            </p:custDataLst>
+          </p:nvPr>
         </p:nvSpPr>
         <p:spPr>
           <a:xfrm>
@@ -16590,7 +16658,11 @@
         <p:nvSpPr>
           <p:cNvPr id="26" name="Rectangle 25"/>
           <p:cNvSpPr/>
-          <p:nvPr/>
+          <p:nvPr>
+            <p:custDataLst>
+              <p:tags r:id="rId18"/>
+            </p:custDataLst>
+          </p:nvPr>
         </p:nvSpPr>
         <p:spPr>
           <a:xfrm>
@@ -16634,7 +16706,11 @@
         <p:nvSpPr>
           <p:cNvPr id="27" name="TextBox 26"/>
           <p:cNvSpPr txBox="1"/>
-          <p:nvPr/>
+          <p:nvPr>
+            <p:custDataLst>
+              <p:tags r:id="rId19"/>
+            </p:custDataLst>
+          </p:nvPr>
         </p:nvSpPr>
         <p:spPr>
           <a:xfrm>
@@ -16687,12 +16763,16 @@
         <p:nvSpPr>
           <p:cNvPr id="28" name="TextBox 27"/>
           <p:cNvSpPr txBox="1"/>
-          <p:nvPr/>
+          <p:nvPr>
+            <p:custDataLst>
+              <p:tags r:id="rId20"/>
+            </p:custDataLst>
+          </p:nvPr>
         </p:nvSpPr>
         <p:spPr>
           <a:xfrm>
             <a:off x="9189719" y="1965960"/>
-            <a:ext cx="2331720" cy="2103120"/>
+            <a:ext cx="2331720" cy="1054100"/>
           </a:xfrm>
           <a:prstGeom prst="rect">
             <a:avLst/>
@@ -16795,7 +16875,7 @@
                 <a:latin typeface="微软雅黑" panose="020B0503020204020204" charset="-122"/>
                 <a:ea typeface="微软雅黑" panose="020B0503020204020204" charset="-122"/>
               </a:rPr>
-              <a:t>● </a:t>
+              <a:t>●</a:t>
             </a:r>
             <a:r>
               <a:rPr sz="1150" b="0" i="0">
@@ -16805,7 +16885,36 @@
                 <a:latin typeface="微软雅黑" panose="020B0503020204020204" charset="-122"/>
                 <a:ea typeface="微软雅黑" panose="020B0503020204020204" charset="-122"/>
               </a:rPr>
-              <a:t>TOP_K=5 · MIN_SIMILARITY=0.30</a:t>
+              <a:t>TOP_K=5 </a:t>
+            </a:r>
+            <a:endParaRPr sz="1150" b="0" i="0">
+              <a:solidFill>
+                <a:srgbClr val="1E293B"/>
+              </a:solidFill>
+              <a:latin typeface="微软雅黑" panose="020B0503020204020204" charset="-122"/>
+              <a:ea typeface="微软雅黑" panose="020B0503020204020204" charset="-122"/>
+            </a:endParaRPr>
+          </a:p>
+          <a:p>
+            <a:pPr marL="171450" indent="-171450">
+              <a:lnSpc>
+                <a:spcPct val="100000"/>
+              </a:lnSpc>
+              <a:spcAft>
+                <a:spcPts val="900"/>
+              </a:spcAft>
+              <a:buFont typeface="Arial" panose="020B0604020202020204" pitchFamily="34" charset="0"/>
+              <a:buChar char="•"/>
+            </a:pPr>
+            <a:r>
+              <a:rPr sz="1150" b="0" i="0">
+                <a:solidFill>
+                  <a:srgbClr val="1E293B"/>
+                </a:solidFill>
+                <a:latin typeface="微软雅黑" panose="020B0503020204020204" charset="-122"/>
+                <a:ea typeface="微软雅黑" panose="020B0503020204020204" charset="-122"/>
+              </a:rPr>
+              <a:t>MIN_SIMILARITY=0.30</a:t>
             </a:r>
             <a:endParaRPr sz="1150" b="0" i="0">
               <a:solidFill>
@@ -33809,7 +33918,7 @@
             <a:r>
               <a:rPr lang="en-US" altLang="zh-CN" sz="1335">
                 <a:solidFill>
-                  <a:srgbClr val="002060"/>
+                  <a:srgbClr val="FF0000"/>
                 </a:solidFill>
                 <a:hlinkClick r:id="rId2" action="ppaction://hlinkfile"/>
               </a:rPr>
@@ -33817,7 +33926,7 @@
             </a:r>
             <a:endParaRPr lang="en-US" altLang="zh-CN" sz="1335">
               <a:solidFill>
-                <a:srgbClr val="002060"/>
+                <a:srgbClr val="FF0000"/>
               </a:solidFill>
             </a:endParaRPr>
           </a:p>
@@ -33828,7 +33937,7 @@
             </a:pPr>
             <a:endParaRPr lang="en-US" altLang="zh-CN" sz="1335">
               <a:solidFill>
-                <a:srgbClr val="002060"/>
+                <a:srgbClr val="FF0000"/>
               </a:solidFill>
             </a:endParaRPr>
           </a:p>
@@ -34491,6 +34600,11 @@
 <file path=ppt/slides/slide27.xml><?xml version="1.0" encoding="utf-8"?>
 <p:sld xmlns:a="http://schemas.openxmlformats.org/drawingml/2006/main" xmlns:r="http://schemas.openxmlformats.org/officeDocument/2006/relationships" xmlns:p="http://schemas.openxmlformats.org/presentationml/2006/main">
   <p:cSld>
+    <p:bg>
+      <p:bgRef idx="1001">
+        <a:schemeClr val="bg1"/>
+      </p:bgRef>
+    </p:bg>
     <p:spTree>
       <p:nvGrpSpPr>
         <p:cNvPr id="1" name=""/>
@@ -34692,63 +34806,10 @@
           </a:p>
         </p:txBody>
       </p:sp>
-      <p:sp>
-        <p:nvSpPr>
-          <p:cNvPr id="8" name="TextBox 7"/>
-          <p:cNvSpPr txBox="1"/>
-          <p:nvPr/>
-        </p:nvSpPr>
-        <p:spPr>
-          <a:xfrm>
-            <a:off x="914400" y="4846320"/>
-            <a:ext cx="10360152" cy="457200"/>
-          </a:xfrm>
-          <a:prstGeom prst="rect">
-            <a:avLst/>
-          </a:prstGeom>
-          <a:noFill/>
-        </p:spPr>
-        <p:txBody>
-          <a:bodyPr wrap="square" lIns="0" tIns="0" rIns="0" bIns="0" anchor="t">
-            <a:spAutoFit/>
-          </a:bodyPr>
-          <a:lstStyle/>
-          <a:p>
-            <a:pPr algn="ctr">
-              <a:lnSpc>
-                <a:spcPct val="100000"/>
-              </a:lnSpc>
-              <a:spcBef>
-                <a:spcPts val="0"/>
-              </a:spcBef>
-              <a:spcAft>
-                <a:spcPts val="0"/>
-              </a:spcAft>
-            </a:pPr>
-            <a:r>
-              <a:rPr sz="1400" b="0" i="0">
-                <a:solidFill>
-                  <a:srgbClr val="9EC9C4"/>
-                </a:solidFill>
-                <a:latin typeface="微软雅黑" panose="020B0503020204020204" charset="-122"/>
-                <a:ea typeface="微软雅黑" panose="020B0503020204020204" charset="-122"/>
-              </a:rPr>
-              <a:t>医智助手 · 医疗知识库智能问答系统</a:t>
-            </a:r>
-            <a:endParaRPr sz="1400" b="0" i="0">
-              <a:solidFill>
-                <a:srgbClr val="9EC9C4"/>
-              </a:solidFill>
-              <a:latin typeface="微软雅黑" panose="020B0503020204020204" charset="-122"/>
-              <a:ea typeface="微软雅黑" panose="020B0503020204020204" charset="-122"/>
-            </a:endParaRPr>
-          </a:p>
-        </p:txBody>
-      </p:sp>
     </p:spTree>
   </p:cSld>
   <p:clrMapOvr>
-    <a:masterClrMapping/>
+    <a:overrideClrMapping bg1="lt1" tx1="dk1" bg2="lt2" tx2="dk2" accent1="accent1" accent2="accent2" accent3="accent3" accent4="accent4" accent5="accent5" accent6="accent6" hlink="hlink" folHlink="folHlink"/>
   </p:clrMapOvr>
 </p:sld>
 </file>
@@ -43377,15 +43438,135 @@
 </p:tagLst>
 </file>
 
+<file path=ppt/tags/tag17.xml><?xml version="1.0" encoding="utf-8"?>
+<p:tagLst xmlns:p="http://schemas.openxmlformats.org/presentationml/2006/main">
+  <p:tag name="KSO_WM_DIAGRAM_VIRTUALLY_FRAME" val="{&quot;height&quot;:226.8,&quot;left&quot;:39.6,&quot;top&quot;:100.8,&quot;width&quot;:882}"/>
+</p:tagLst>
+</file>
+
+<file path=ppt/tags/tag18.xml><?xml version="1.0" encoding="utf-8"?>
+<p:tagLst xmlns:p="http://schemas.openxmlformats.org/presentationml/2006/main">
+  <p:tag name="KSO_WM_DIAGRAM_VIRTUALLY_FRAME" val="{&quot;height&quot;:226.8,&quot;left&quot;:39.6,&quot;top&quot;:100.8,&quot;width&quot;:882}"/>
+</p:tagLst>
+</file>
+
+<file path=ppt/tags/tag19.xml><?xml version="1.0" encoding="utf-8"?>
+<p:tagLst xmlns:p="http://schemas.openxmlformats.org/presentationml/2006/main">
+  <p:tag name="KSO_WM_DIAGRAM_VIRTUALLY_FRAME" val="{&quot;height&quot;:226.8,&quot;left&quot;:39.6,&quot;top&quot;:100.8,&quot;width&quot;:882}"/>
+</p:tagLst>
+</file>
+
 <file path=ppt/tags/tag2.xml><?xml version="1.0" encoding="utf-8"?>
 <p:tagLst xmlns:p="http://schemas.openxmlformats.org/presentationml/2006/main">
   <p:tag name="KSO_WM_DIAGRAM_VIRTUALLY_FRAME" val="{&quot;height&quot;:352.8,&quot;left&quot;:39.6,&quot;top&quot;:104.4,&quot;width&quot;:882}"/>
 </p:tagLst>
 </file>
 
+<file path=ppt/tags/tag20.xml><?xml version="1.0" encoding="utf-8"?>
+<p:tagLst xmlns:p="http://schemas.openxmlformats.org/presentationml/2006/main">
+  <p:tag name="KSO_WM_DIAGRAM_VIRTUALLY_FRAME" val="{&quot;height&quot;:226.8,&quot;left&quot;:39.6,&quot;top&quot;:100.8,&quot;width&quot;:882}"/>
+</p:tagLst>
+</file>
+
+<file path=ppt/tags/tag21.xml><?xml version="1.0" encoding="utf-8"?>
+<p:tagLst xmlns:p="http://schemas.openxmlformats.org/presentationml/2006/main">
+  <p:tag name="KSO_WM_DIAGRAM_VIRTUALLY_FRAME" val="{&quot;height&quot;:226.8,&quot;left&quot;:39.6,&quot;top&quot;:100.8,&quot;width&quot;:882}"/>
+</p:tagLst>
+</file>
+
+<file path=ppt/tags/tag22.xml><?xml version="1.0" encoding="utf-8"?>
+<p:tagLst xmlns:p="http://schemas.openxmlformats.org/presentationml/2006/main">
+  <p:tag name="KSO_WM_DIAGRAM_VIRTUALLY_FRAME" val="{&quot;height&quot;:226.8,&quot;left&quot;:39.6,&quot;top&quot;:100.8,&quot;width&quot;:882}"/>
+</p:tagLst>
+</file>
+
+<file path=ppt/tags/tag23.xml><?xml version="1.0" encoding="utf-8"?>
+<p:tagLst xmlns:p="http://schemas.openxmlformats.org/presentationml/2006/main">
+  <p:tag name="KSO_WM_DIAGRAM_VIRTUALLY_FRAME" val="{&quot;height&quot;:226.8,&quot;left&quot;:39.6,&quot;top&quot;:100.8,&quot;width&quot;:882}"/>
+</p:tagLst>
+</file>
+
+<file path=ppt/tags/tag24.xml><?xml version="1.0" encoding="utf-8"?>
+<p:tagLst xmlns:p="http://schemas.openxmlformats.org/presentationml/2006/main">
+  <p:tag name="KSO_WM_DIAGRAM_VIRTUALLY_FRAME" val="{&quot;height&quot;:226.8,&quot;left&quot;:39.6,&quot;top&quot;:100.8,&quot;width&quot;:882}"/>
+</p:tagLst>
+</file>
+
+<file path=ppt/tags/tag25.xml><?xml version="1.0" encoding="utf-8"?>
+<p:tagLst xmlns:p="http://schemas.openxmlformats.org/presentationml/2006/main">
+  <p:tag name="KSO_WM_DIAGRAM_VIRTUALLY_FRAME" val="{&quot;height&quot;:226.8,&quot;left&quot;:39.6,&quot;top&quot;:100.8,&quot;width&quot;:882}"/>
+</p:tagLst>
+</file>
+
+<file path=ppt/tags/tag26.xml><?xml version="1.0" encoding="utf-8"?>
+<p:tagLst xmlns:p="http://schemas.openxmlformats.org/presentationml/2006/main">
+  <p:tag name="KSO_WM_DIAGRAM_VIRTUALLY_FRAME" val="{&quot;height&quot;:226.8,&quot;left&quot;:39.6,&quot;top&quot;:100.8,&quot;width&quot;:882}"/>
+</p:tagLst>
+</file>
+
+<file path=ppt/tags/tag27.xml><?xml version="1.0" encoding="utf-8"?>
+<p:tagLst xmlns:p="http://schemas.openxmlformats.org/presentationml/2006/main">
+  <p:tag name="KSO_WM_DIAGRAM_VIRTUALLY_FRAME" val="{&quot;height&quot;:226.8,&quot;left&quot;:39.6,&quot;top&quot;:100.8,&quot;width&quot;:882}"/>
+</p:tagLst>
+</file>
+
+<file path=ppt/tags/tag28.xml><?xml version="1.0" encoding="utf-8"?>
+<p:tagLst xmlns:p="http://schemas.openxmlformats.org/presentationml/2006/main">
+  <p:tag name="KSO_WM_DIAGRAM_VIRTUALLY_FRAME" val="{&quot;height&quot;:226.8,&quot;left&quot;:39.6,&quot;top&quot;:100.8,&quot;width&quot;:882}"/>
+</p:tagLst>
+</file>
+
+<file path=ppt/tags/tag29.xml><?xml version="1.0" encoding="utf-8"?>
+<p:tagLst xmlns:p="http://schemas.openxmlformats.org/presentationml/2006/main">
+  <p:tag name="KSO_WM_DIAGRAM_VIRTUALLY_FRAME" val="{&quot;height&quot;:226.8,&quot;left&quot;:39.6,&quot;top&quot;:100.8,&quot;width&quot;:882}"/>
+</p:tagLst>
+</file>
+
 <file path=ppt/tags/tag3.xml><?xml version="1.0" encoding="utf-8"?>
 <p:tagLst xmlns:p="http://schemas.openxmlformats.org/presentationml/2006/main">
   <p:tag name="KSO_WM_DIAGRAM_VIRTUALLY_FRAME" val="{&quot;height&quot;:352.8,&quot;left&quot;:39.6,&quot;top&quot;:104.4,&quot;width&quot;:882}"/>
+</p:tagLst>
+</file>
+
+<file path=ppt/tags/tag30.xml><?xml version="1.0" encoding="utf-8"?>
+<p:tagLst xmlns:p="http://schemas.openxmlformats.org/presentationml/2006/main">
+  <p:tag name="KSO_WM_DIAGRAM_VIRTUALLY_FRAME" val="{&quot;height&quot;:226.8,&quot;left&quot;:39.6,&quot;top&quot;:100.8,&quot;width&quot;:882}"/>
+</p:tagLst>
+</file>
+
+<file path=ppt/tags/tag31.xml><?xml version="1.0" encoding="utf-8"?>
+<p:tagLst xmlns:p="http://schemas.openxmlformats.org/presentationml/2006/main">
+  <p:tag name="KSO_WM_DIAGRAM_VIRTUALLY_FRAME" val="{&quot;height&quot;:226.8,&quot;left&quot;:39.6,&quot;top&quot;:100.8,&quot;width&quot;:882}"/>
+</p:tagLst>
+</file>
+
+<file path=ppt/tags/tag32.xml><?xml version="1.0" encoding="utf-8"?>
+<p:tagLst xmlns:p="http://schemas.openxmlformats.org/presentationml/2006/main">
+  <p:tag name="KSO_WM_DIAGRAM_VIRTUALLY_FRAME" val="{&quot;height&quot;:226.8,&quot;left&quot;:39.6,&quot;top&quot;:100.8,&quot;width&quot;:882}"/>
+</p:tagLst>
+</file>
+
+<file path=ppt/tags/tag33.xml><?xml version="1.0" encoding="utf-8"?>
+<p:tagLst xmlns:p="http://schemas.openxmlformats.org/presentationml/2006/main">
+  <p:tag name="KSO_WM_DIAGRAM_VIRTUALLY_FRAME" val="{&quot;height&quot;:226.8,&quot;left&quot;:39.6,&quot;top&quot;:100.8,&quot;width&quot;:882}"/>
+</p:tagLst>
+</file>
+
+<file path=ppt/tags/tag34.xml><?xml version="1.0" encoding="utf-8"?>
+<p:tagLst xmlns:p="http://schemas.openxmlformats.org/presentationml/2006/main">
+  <p:tag name="KSO_WM_DIAGRAM_VIRTUALLY_FRAME" val="{&quot;height&quot;:226.8,&quot;left&quot;:39.6,&quot;top&quot;:100.8,&quot;width&quot;:882}"/>
+</p:tagLst>
+</file>
+
+<file path=ppt/tags/tag35.xml><?xml version="1.0" encoding="utf-8"?>
+<p:tagLst xmlns:p="http://schemas.openxmlformats.org/presentationml/2006/main">
+  <p:tag name="KSO_WM_DIAGRAM_VIRTUALLY_FRAME" val="{&quot;height&quot;:226.8,&quot;left&quot;:39.6,&quot;top&quot;:100.8,&quot;width&quot;:882}"/>
+</p:tagLst>
+</file>
+
+<file path=ppt/tags/tag36.xml><?xml version="1.0" encoding="utf-8"?>
+<p:tagLst xmlns:p="http://schemas.openxmlformats.org/presentationml/2006/main">
+  <p:tag name="KSO_WM_DIAGRAM_VIRTUALLY_FRAME" val="{&quot;height&quot;:226.8,&quot;left&quot;:39.6,&quot;top&quot;:100.8,&quot;width&quot;:882}"/>
 </p:tagLst>
 </file>
 
@@ -43747,4 +43928,47 @@
     </a:ext>
   </a:extLst>
 </a:theme>
+</file>
+
+<file path=ppt/theme/themeOverride1.xml><?xml version="1.0" encoding="utf-8"?>
+<a:themeOverride xmlns:a="http://schemas.openxmlformats.org/drawingml/2006/main">
+  <a:clrScheme name="Office">
+    <a:dk1>
+      <a:sysClr val="windowText" lastClr="000000"/>
+    </a:dk1>
+    <a:lt1>
+      <a:sysClr val="window" lastClr="FFFFFF"/>
+    </a:lt1>
+    <a:dk2>
+      <a:srgbClr val="1F497D"/>
+    </a:dk2>
+    <a:lt2>
+      <a:srgbClr val="EEECE1"/>
+    </a:lt2>
+    <a:accent1>
+      <a:srgbClr val="4F81BD"/>
+    </a:accent1>
+    <a:accent2>
+      <a:srgbClr val="C0504D"/>
+    </a:accent2>
+    <a:accent3>
+      <a:srgbClr val="9BBB59"/>
+    </a:accent3>
+    <a:accent4>
+      <a:srgbClr val="8064A2"/>
+    </a:accent4>
+    <a:accent5>
+      <a:srgbClr val="4BACC6"/>
+    </a:accent5>
+    <a:accent6>
+      <a:srgbClr val="F79646"/>
+    </a:accent6>
+    <a:hlink>
+      <a:srgbClr val="0000FF"/>
+    </a:hlink>
+    <a:folHlink>
+      <a:srgbClr val="800080"/>
+    </a:folHlink>
+  </a:clrScheme>
+</a:themeOverride>
 </file>
</xml_diff>